<commit_message>
Fix pptx — strip auto-added theme refs and connectors that broke Google Slides import
</commit_message>
<xml_diff>
--- a/pitchdeck/STRATA_case_study.pptx
+++ b/pitchdeck/STRATA_case_study.pptx
@@ -3127,22 +3127,7 @@
           <a:ln>
             <a:noFill/>
           </a:ln>
-          <a:effectLst/>
-        </p:spPr>
-        <p:style>
-          <a:lnRef idx="1">
-            <a:schemeClr val="accent1"/>
-          </a:lnRef>
-          <a:fillRef idx="3">
-            <a:schemeClr val="accent1"/>
-          </a:fillRef>
-          <a:effectRef idx="2">
-            <a:schemeClr val="accent1"/>
-          </a:effectRef>
-          <a:fontRef idx="minor">
-            <a:schemeClr val="lt1"/>
-          </a:fontRef>
-        </p:style>
+        </p:spPr>
         <p:txBody>
           <a:bodyPr rtlCol="0" anchor="ctr"/>
           <a:lstStyle/>
@@ -3171,22 +3156,7 @@
           <a:ln>
             <a:noFill/>
           </a:ln>
-          <a:effectLst/>
-        </p:spPr>
-        <p:style>
-          <a:lnRef idx="1">
-            <a:schemeClr val="accent1"/>
-          </a:lnRef>
-          <a:fillRef idx="3">
-            <a:schemeClr val="accent1"/>
-          </a:fillRef>
-          <a:effectRef idx="2">
-            <a:schemeClr val="accent1"/>
-          </a:effectRef>
-          <a:fontRef idx="minor">
-            <a:schemeClr val="lt1"/>
-          </a:fontRef>
-        </p:style>
+        </p:spPr>
         <p:txBody>
           <a:bodyPr rtlCol="0" anchor="ctr"/>
           <a:lstStyle/>
@@ -3215,22 +3185,7 @@
           <a:ln>
             <a:noFill/>
           </a:ln>
-          <a:effectLst/>
-        </p:spPr>
-        <p:style>
-          <a:lnRef idx="1">
-            <a:schemeClr val="accent1"/>
-          </a:lnRef>
-          <a:fillRef idx="3">
-            <a:schemeClr val="accent1"/>
-          </a:fillRef>
-          <a:effectRef idx="2">
-            <a:schemeClr val="accent1"/>
-          </a:effectRef>
-          <a:fontRef idx="minor">
-            <a:schemeClr val="lt1"/>
-          </a:fontRef>
-        </p:style>
+        </p:spPr>
         <p:txBody>
           <a:bodyPr rtlCol="0" anchor="ctr"/>
           <a:lstStyle/>
@@ -3573,41 +3528,35 @@
           </a:p>
         </p:txBody>
       </p:sp>
-      <p:cxnSp>
-        <p:nvCxnSpPr>
-          <p:cNvPr id="12" name="Connector 11"/>
-          <p:cNvCxnSpPr/>
-          <p:nvPr/>
-        </p:nvCxnSpPr>
-        <p:spPr>
-          <a:xfrm>
-            <a:off x="548640" y="5532120"/>
-            <a:ext cx="11064240" cy="0"/>
-          </a:xfrm>
-          <a:prstGeom prst="line">
-            <a:avLst/>
-          </a:prstGeom>
-          <a:ln w="9525">
-            <a:solidFill>
-              <a:srgbClr val="EAE5DD"/>
-            </a:solidFill>
+      <p:sp>
+        <p:nvSpPr>
+          <p:cNvPr id="12" name="Rectangle 11"/>
+          <p:cNvSpPr/>
+          <p:nvPr/>
+        </p:nvSpPr>
+        <p:spPr>
+          <a:xfrm>
+            <a:off x="548640" y="5527358"/>
+            <a:ext cx="11064240" cy="9525"/>
+          </a:xfrm>
+          <a:prstGeom prst="rect">
+            <a:avLst/>
+          </a:prstGeom>
+          <a:solidFill>
+            <a:srgbClr val="EAE5DD"/>
+          </a:solidFill>
+          <a:ln>
+            <a:noFill/>
           </a:ln>
         </p:spPr>
-        <p:style>
-          <a:lnRef idx="2">
-            <a:schemeClr val="accent1"/>
-          </a:lnRef>
-          <a:fillRef idx="0">
-            <a:schemeClr val="accent1"/>
-          </a:fillRef>
-          <a:effectRef idx="1">
-            <a:schemeClr val="accent1"/>
-          </a:effectRef>
-          <a:fontRef idx="minor">
-            <a:schemeClr val="tx1"/>
-          </a:fontRef>
-        </p:style>
-      </p:cxnSp>
+        <p:txBody>
+          <a:bodyPr rtlCol="0" anchor="ctr"/>
+          <a:lstStyle/>
+          <a:p>
+            <a:pPr algn="ctr"/>
+          </a:p>
+        </p:txBody>
+      </p:sp>
       <p:sp>
         <p:nvSpPr>
           <p:cNvPr id="13" name="TextBox 12"/>
@@ -3778,22 +3727,7 @@
               <a:srgbClr val="EAE5DD"/>
             </a:solidFill>
           </a:ln>
-          <a:effectLst/>
-        </p:spPr>
-        <p:style>
-          <a:lnRef idx="1">
-            <a:schemeClr val="accent1"/>
-          </a:lnRef>
-          <a:fillRef idx="3">
-            <a:schemeClr val="accent1"/>
-          </a:fillRef>
-          <a:effectRef idx="2">
-            <a:schemeClr val="accent1"/>
-          </a:effectRef>
-          <a:fontRef idx="minor">
-            <a:schemeClr val="lt1"/>
-          </a:fontRef>
-        </p:style>
+        </p:spPr>
         <p:txBody>
           <a:bodyPr rtlCol="0" anchor="ctr"/>
           <a:lstStyle/>
@@ -3822,22 +3756,7 @@
           <a:ln>
             <a:noFill/>
           </a:ln>
-          <a:effectLst/>
-        </p:spPr>
-        <p:style>
-          <a:lnRef idx="1">
-            <a:schemeClr val="accent1"/>
-          </a:lnRef>
-          <a:fillRef idx="3">
-            <a:schemeClr val="accent1"/>
-          </a:fillRef>
-          <a:effectRef idx="2">
-            <a:schemeClr val="accent1"/>
-          </a:effectRef>
-          <a:fontRef idx="minor">
-            <a:schemeClr val="lt1"/>
-          </a:fontRef>
-        </p:style>
+        </p:spPr>
         <p:txBody>
           <a:bodyPr rtlCol="0" anchor="ctr"/>
           <a:lstStyle/>
@@ -4006,22 +3925,7 @@
               <a:srgbClr val="EAE5DD"/>
             </a:solidFill>
           </a:ln>
-          <a:effectLst/>
-        </p:spPr>
-        <p:style>
-          <a:lnRef idx="1">
-            <a:schemeClr val="accent1"/>
-          </a:lnRef>
-          <a:fillRef idx="3">
-            <a:schemeClr val="accent1"/>
-          </a:fillRef>
-          <a:effectRef idx="2">
-            <a:schemeClr val="accent1"/>
-          </a:effectRef>
-          <a:fontRef idx="minor">
-            <a:schemeClr val="lt1"/>
-          </a:fontRef>
-        </p:style>
+        </p:spPr>
         <p:txBody>
           <a:bodyPr rtlCol="0" anchor="ctr"/>
           <a:lstStyle/>
@@ -4089,22 +3993,7 @@
               <a:srgbClr val="EAE5DD"/>
             </a:solidFill>
           </a:ln>
-          <a:effectLst/>
-        </p:spPr>
-        <p:style>
-          <a:lnRef idx="1">
-            <a:schemeClr val="accent1"/>
-          </a:lnRef>
-          <a:fillRef idx="3">
-            <a:schemeClr val="accent1"/>
-          </a:fillRef>
-          <a:effectRef idx="2">
-            <a:schemeClr val="accent1"/>
-          </a:effectRef>
-          <a:fontRef idx="minor">
-            <a:schemeClr val="lt1"/>
-          </a:fontRef>
-        </p:style>
+        </p:spPr>
         <p:txBody>
           <a:bodyPr rtlCol="0" anchor="ctr"/>
           <a:lstStyle/>
@@ -4133,22 +4022,7 @@
           <a:ln>
             <a:noFill/>
           </a:ln>
-          <a:effectLst/>
-        </p:spPr>
-        <p:style>
-          <a:lnRef idx="1">
-            <a:schemeClr val="accent1"/>
-          </a:lnRef>
-          <a:fillRef idx="3">
-            <a:schemeClr val="accent1"/>
-          </a:fillRef>
-          <a:effectRef idx="2">
-            <a:schemeClr val="accent1"/>
-          </a:effectRef>
-          <a:fontRef idx="minor">
-            <a:schemeClr val="lt1"/>
-          </a:fontRef>
-        </p:style>
+        </p:spPr>
         <p:txBody>
           <a:bodyPr rtlCol="0" anchor="ctr"/>
           <a:lstStyle/>
@@ -4265,22 +4139,7 @@
               <a:srgbClr val="EAE5DD"/>
             </a:solidFill>
           </a:ln>
-          <a:effectLst/>
-        </p:spPr>
-        <p:style>
-          <a:lnRef idx="1">
-            <a:schemeClr val="accent1"/>
-          </a:lnRef>
-          <a:fillRef idx="3">
-            <a:schemeClr val="accent1"/>
-          </a:fillRef>
-          <a:effectRef idx="2">
-            <a:schemeClr val="accent1"/>
-          </a:effectRef>
-          <a:fontRef idx="minor">
-            <a:schemeClr val="lt1"/>
-          </a:fontRef>
-        </p:style>
+        </p:spPr>
         <p:txBody>
           <a:bodyPr rtlCol="0" anchor="ctr"/>
           <a:lstStyle/>
@@ -4309,22 +4168,7 @@
           <a:ln>
             <a:noFill/>
           </a:ln>
-          <a:effectLst/>
-        </p:spPr>
-        <p:style>
-          <a:lnRef idx="1">
-            <a:schemeClr val="accent1"/>
-          </a:lnRef>
-          <a:fillRef idx="3">
-            <a:schemeClr val="accent1"/>
-          </a:fillRef>
-          <a:effectRef idx="2">
-            <a:schemeClr val="accent1"/>
-          </a:effectRef>
-          <a:fontRef idx="minor">
-            <a:schemeClr val="lt1"/>
-          </a:fontRef>
-        </p:style>
+        </p:spPr>
         <p:txBody>
           <a:bodyPr rtlCol="0" anchor="ctr"/>
           <a:lstStyle/>
@@ -4441,22 +4285,7 @@
               <a:srgbClr val="EAE5DD"/>
             </a:solidFill>
           </a:ln>
-          <a:effectLst/>
-        </p:spPr>
-        <p:style>
-          <a:lnRef idx="1">
-            <a:schemeClr val="accent1"/>
-          </a:lnRef>
-          <a:fillRef idx="3">
-            <a:schemeClr val="accent1"/>
-          </a:fillRef>
-          <a:effectRef idx="2">
-            <a:schemeClr val="accent1"/>
-          </a:effectRef>
-          <a:fontRef idx="minor">
-            <a:schemeClr val="lt1"/>
-          </a:fontRef>
-        </p:style>
+        </p:spPr>
         <p:txBody>
           <a:bodyPr rtlCol="0" anchor="ctr"/>
           <a:lstStyle/>
@@ -4485,22 +4314,7 @@
           <a:ln>
             <a:noFill/>
           </a:ln>
-          <a:effectLst/>
-        </p:spPr>
-        <p:style>
-          <a:lnRef idx="1">
-            <a:schemeClr val="accent1"/>
-          </a:lnRef>
-          <a:fillRef idx="3">
-            <a:schemeClr val="accent1"/>
-          </a:fillRef>
-          <a:effectRef idx="2">
-            <a:schemeClr val="accent1"/>
-          </a:effectRef>
-          <a:fontRef idx="minor">
-            <a:schemeClr val="lt1"/>
-          </a:fontRef>
-        </p:style>
+        </p:spPr>
         <p:txBody>
           <a:bodyPr rtlCol="0" anchor="ctr"/>
           <a:lstStyle/>
@@ -4617,22 +4431,7 @@
               <a:srgbClr val="EAE5DD"/>
             </a:solidFill>
           </a:ln>
-          <a:effectLst/>
-        </p:spPr>
-        <p:style>
-          <a:lnRef idx="1">
-            <a:schemeClr val="accent1"/>
-          </a:lnRef>
-          <a:fillRef idx="3">
-            <a:schemeClr val="accent1"/>
-          </a:fillRef>
-          <a:effectRef idx="2">
-            <a:schemeClr val="accent1"/>
-          </a:effectRef>
-          <a:fontRef idx="minor">
-            <a:schemeClr val="lt1"/>
-          </a:fontRef>
-        </p:style>
+        </p:spPr>
         <p:txBody>
           <a:bodyPr rtlCol="0" anchor="ctr"/>
           <a:lstStyle/>
@@ -4661,22 +4460,7 @@
           <a:ln>
             <a:noFill/>
           </a:ln>
-          <a:effectLst/>
-        </p:spPr>
-        <p:style>
-          <a:lnRef idx="1">
-            <a:schemeClr val="accent1"/>
-          </a:lnRef>
-          <a:fillRef idx="3">
-            <a:schemeClr val="accent1"/>
-          </a:fillRef>
-          <a:effectRef idx="2">
-            <a:schemeClr val="accent1"/>
-          </a:effectRef>
-          <a:fontRef idx="minor">
-            <a:schemeClr val="lt1"/>
-          </a:fontRef>
-        </p:style>
+        </p:spPr>
         <p:txBody>
           <a:bodyPr rtlCol="0" anchor="ctr"/>
           <a:lstStyle/>
@@ -4793,22 +4577,7 @@
               <a:srgbClr val="EAE5DD"/>
             </a:solidFill>
           </a:ln>
-          <a:effectLst/>
-        </p:spPr>
-        <p:style>
-          <a:lnRef idx="1">
-            <a:schemeClr val="accent1"/>
-          </a:lnRef>
-          <a:fillRef idx="3">
-            <a:schemeClr val="accent1"/>
-          </a:fillRef>
-          <a:effectRef idx="2">
-            <a:schemeClr val="accent1"/>
-          </a:effectRef>
-          <a:fontRef idx="minor">
-            <a:schemeClr val="lt1"/>
-          </a:fontRef>
-        </p:style>
+        </p:spPr>
         <p:txBody>
           <a:bodyPr rtlCol="0" anchor="ctr"/>
           <a:lstStyle/>
@@ -5372,22 +5141,7 @@
               <a:srgbClr val="EAE5DD"/>
             </a:solidFill>
           </a:ln>
-          <a:effectLst/>
-        </p:spPr>
-        <p:style>
-          <a:lnRef idx="1">
-            <a:schemeClr val="accent1"/>
-          </a:lnRef>
-          <a:fillRef idx="3">
-            <a:schemeClr val="accent1"/>
-          </a:fillRef>
-          <a:effectRef idx="2">
-            <a:schemeClr val="accent1"/>
-          </a:effectRef>
-          <a:fontRef idx="minor">
-            <a:schemeClr val="lt1"/>
-          </a:fontRef>
-        </p:style>
+        </p:spPr>
         <p:txBody>
           <a:bodyPr rtlCol="0" anchor="ctr"/>
           <a:lstStyle/>
@@ -5416,22 +5170,7 @@
           <a:ln>
             <a:noFill/>
           </a:ln>
-          <a:effectLst/>
-        </p:spPr>
-        <p:style>
-          <a:lnRef idx="1">
-            <a:schemeClr val="accent1"/>
-          </a:lnRef>
-          <a:fillRef idx="3">
-            <a:schemeClr val="accent1"/>
-          </a:fillRef>
-          <a:effectRef idx="2">
-            <a:schemeClr val="accent1"/>
-          </a:effectRef>
-          <a:fontRef idx="minor">
-            <a:schemeClr val="lt1"/>
-          </a:fontRef>
-        </p:style>
+        </p:spPr>
         <p:txBody>
           <a:bodyPr rtlCol="0" anchor="ctr"/>
           <a:lstStyle/>
@@ -5462,22 +5201,7 @@
           <a:ln>
             <a:noFill/>
           </a:ln>
-          <a:effectLst/>
-        </p:spPr>
-        <p:style>
-          <a:lnRef idx="1">
-            <a:schemeClr val="accent1"/>
-          </a:lnRef>
-          <a:fillRef idx="3">
-            <a:schemeClr val="accent1"/>
-          </a:fillRef>
-          <a:effectRef idx="2">
-            <a:schemeClr val="accent1"/>
-          </a:effectRef>
-          <a:fontRef idx="minor">
-            <a:schemeClr val="lt1"/>
-          </a:fontRef>
-        </p:style>
+        </p:spPr>
         <p:txBody>
           <a:bodyPr rtlCol="0" anchor="ctr"/>
           <a:lstStyle/>
@@ -5671,22 +5395,7 @@
               <a:srgbClr val="EAE5DD"/>
             </a:solidFill>
           </a:ln>
-          <a:effectLst/>
-        </p:spPr>
-        <p:style>
-          <a:lnRef idx="1">
-            <a:schemeClr val="accent1"/>
-          </a:lnRef>
-          <a:fillRef idx="3">
-            <a:schemeClr val="accent1"/>
-          </a:fillRef>
-          <a:effectRef idx="2">
-            <a:schemeClr val="accent1"/>
-          </a:effectRef>
-          <a:fontRef idx="minor">
-            <a:schemeClr val="lt1"/>
-          </a:fontRef>
-        </p:style>
+        </p:spPr>
         <p:txBody>
           <a:bodyPr rtlCol="0" anchor="ctr"/>
           <a:lstStyle/>
@@ -6088,22 +5797,7 @@
               <a:srgbClr val="EAE5DD"/>
             </a:solidFill>
           </a:ln>
-          <a:effectLst/>
-        </p:spPr>
-        <p:style>
-          <a:lnRef idx="1">
-            <a:schemeClr val="accent1"/>
-          </a:lnRef>
-          <a:fillRef idx="3">
-            <a:schemeClr val="accent1"/>
-          </a:fillRef>
-          <a:effectRef idx="2">
-            <a:schemeClr val="accent1"/>
-          </a:effectRef>
-          <a:fontRef idx="minor">
-            <a:schemeClr val="lt1"/>
-          </a:fontRef>
-        </p:style>
+        </p:spPr>
         <p:txBody>
           <a:bodyPr rtlCol="0" anchor="ctr"/>
           <a:lstStyle/>
@@ -6227,22 +5921,7 @@
               <a:srgbClr val="EAE5DD"/>
             </a:solidFill>
           </a:ln>
-          <a:effectLst/>
-        </p:spPr>
-        <p:style>
-          <a:lnRef idx="1">
-            <a:schemeClr val="accent1"/>
-          </a:lnRef>
-          <a:fillRef idx="3">
-            <a:schemeClr val="accent1"/>
-          </a:fillRef>
-          <a:effectRef idx="2">
-            <a:schemeClr val="accent1"/>
-          </a:effectRef>
-          <a:fontRef idx="minor">
-            <a:schemeClr val="lt1"/>
-          </a:fontRef>
-        </p:style>
+        </p:spPr>
         <p:txBody>
           <a:bodyPr rtlCol="0" anchor="ctr"/>
           <a:lstStyle/>
@@ -6366,22 +6045,7 @@
               <a:srgbClr val="EAE5DD"/>
             </a:solidFill>
           </a:ln>
-          <a:effectLst/>
-        </p:spPr>
-        <p:style>
-          <a:lnRef idx="1">
-            <a:schemeClr val="accent1"/>
-          </a:lnRef>
-          <a:fillRef idx="3">
-            <a:schemeClr val="accent1"/>
-          </a:fillRef>
-          <a:effectRef idx="2">
-            <a:schemeClr val="accent1"/>
-          </a:effectRef>
-          <a:fontRef idx="minor">
-            <a:schemeClr val="lt1"/>
-          </a:fontRef>
-        </p:style>
+        </p:spPr>
         <p:txBody>
           <a:bodyPr rtlCol="0" anchor="ctr"/>
           <a:lstStyle/>
@@ -6505,22 +6169,7 @@
               <a:srgbClr val="EAE5DD"/>
             </a:solidFill>
           </a:ln>
-          <a:effectLst/>
-        </p:spPr>
-        <p:style>
-          <a:lnRef idx="1">
-            <a:schemeClr val="accent1"/>
-          </a:lnRef>
-          <a:fillRef idx="3">
-            <a:schemeClr val="accent1"/>
-          </a:fillRef>
-          <a:effectRef idx="2">
-            <a:schemeClr val="accent1"/>
-          </a:effectRef>
-          <a:fontRef idx="minor">
-            <a:schemeClr val="lt1"/>
-          </a:fontRef>
-        </p:style>
+        </p:spPr>
         <p:txBody>
           <a:bodyPr rtlCol="0" anchor="ctr"/>
           <a:lstStyle/>
@@ -6549,22 +6198,7 @@
           <a:ln>
             <a:noFill/>
           </a:ln>
-          <a:effectLst/>
-        </p:spPr>
-        <p:style>
-          <a:lnRef idx="1">
-            <a:schemeClr val="accent1"/>
-          </a:lnRef>
-          <a:fillRef idx="3">
-            <a:schemeClr val="accent1"/>
-          </a:fillRef>
-          <a:effectRef idx="2">
-            <a:schemeClr val="accent1"/>
-          </a:effectRef>
-          <a:fontRef idx="minor">
-            <a:schemeClr val="lt1"/>
-          </a:fontRef>
-        </p:style>
+        </p:spPr>
         <p:txBody>
           <a:bodyPr rtlCol="0" anchor="ctr"/>
           <a:lstStyle/>
@@ -6933,22 +6567,7 @@
               <a:srgbClr val="EAE5DD"/>
             </a:solidFill>
           </a:ln>
-          <a:effectLst/>
-        </p:spPr>
-        <p:style>
-          <a:lnRef idx="1">
-            <a:schemeClr val="accent1"/>
-          </a:lnRef>
-          <a:fillRef idx="3">
-            <a:schemeClr val="accent1"/>
-          </a:fillRef>
-          <a:effectRef idx="2">
-            <a:schemeClr val="accent1"/>
-          </a:effectRef>
-          <a:fontRef idx="minor">
-            <a:schemeClr val="lt1"/>
-          </a:fontRef>
-        </p:style>
+        </p:spPr>
         <p:txBody>
           <a:bodyPr rtlCol="0" anchor="ctr"/>
           <a:lstStyle/>
@@ -6977,22 +6596,7 @@
           <a:ln>
             <a:noFill/>
           </a:ln>
-          <a:effectLst/>
-        </p:spPr>
-        <p:style>
-          <a:lnRef idx="1">
-            <a:schemeClr val="accent1"/>
-          </a:lnRef>
-          <a:fillRef idx="3">
-            <a:schemeClr val="accent1"/>
-          </a:fillRef>
-          <a:effectRef idx="2">
-            <a:schemeClr val="accent1"/>
-          </a:effectRef>
-          <a:fontRef idx="minor">
-            <a:schemeClr val="lt1"/>
-          </a:fontRef>
-        </p:style>
+        </p:spPr>
         <p:txBody>
           <a:bodyPr rtlCol="0" anchor="ctr"/>
           <a:lstStyle/>
@@ -7075,22 +6679,7 @@
               <a:srgbClr val="EAE5DD"/>
             </a:solidFill>
           </a:ln>
-          <a:effectLst/>
-        </p:spPr>
-        <p:style>
-          <a:lnRef idx="1">
-            <a:schemeClr val="accent1"/>
-          </a:lnRef>
-          <a:fillRef idx="3">
-            <a:schemeClr val="accent1"/>
-          </a:fillRef>
-          <a:effectRef idx="2">
-            <a:schemeClr val="accent1"/>
-          </a:effectRef>
-          <a:fontRef idx="minor">
-            <a:schemeClr val="lt1"/>
-          </a:fontRef>
-        </p:style>
+        </p:spPr>
         <p:txBody>
           <a:bodyPr rtlCol="0" anchor="ctr"/>
           <a:lstStyle/>
@@ -7119,22 +6708,7 @@
           <a:ln>
             <a:noFill/>
           </a:ln>
-          <a:effectLst/>
-        </p:spPr>
-        <p:style>
-          <a:lnRef idx="1">
-            <a:schemeClr val="accent1"/>
-          </a:lnRef>
-          <a:fillRef idx="3">
-            <a:schemeClr val="accent1"/>
-          </a:fillRef>
-          <a:effectRef idx="2">
-            <a:schemeClr val="accent1"/>
-          </a:effectRef>
-          <a:fontRef idx="minor">
-            <a:schemeClr val="lt1"/>
-          </a:fontRef>
-        </p:style>
+        </p:spPr>
         <p:txBody>
           <a:bodyPr rtlCol="0" anchor="ctr"/>
           <a:lstStyle/>
@@ -7217,22 +6791,7 @@
               <a:srgbClr val="EAE5DD"/>
             </a:solidFill>
           </a:ln>
-          <a:effectLst/>
-        </p:spPr>
-        <p:style>
-          <a:lnRef idx="1">
-            <a:schemeClr val="accent1"/>
-          </a:lnRef>
-          <a:fillRef idx="3">
-            <a:schemeClr val="accent1"/>
-          </a:fillRef>
-          <a:effectRef idx="2">
-            <a:schemeClr val="accent1"/>
-          </a:effectRef>
-          <a:fontRef idx="minor">
-            <a:schemeClr val="lt1"/>
-          </a:fontRef>
-        </p:style>
+        </p:spPr>
         <p:txBody>
           <a:bodyPr rtlCol="0" anchor="ctr"/>
           <a:lstStyle/>
@@ -7261,22 +6820,7 @@
           <a:ln>
             <a:noFill/>
           </a:ln>
-          <a:effectLst/>
-        </p:spPr>
-        <p:style>
-          <a:lnRef idx="1">
-            <a:schemeClr val="accent1"/>
-          </a:lnRef>
-          <a:fillRef idx="3">
-            <a:schemeClr val="accent1"/>
-          </a:fillRef>
-          <a:effectRef idx="2">
-            <a:schemeClr val="accent1"/>
-          </a:effectRef>
-          <a:fontRef idx="minor">
-            <a:schemeClr val="lt1"/>
-          </a:fontRef>
-        </p:style>
+        </p:spPr>
         <p:txBody>
           <a:bodyPr rtlCol="0" anchor="ctr"/>
           <a:lstStyle/>
@@ -7505,22 +7049,7 @@
               <a:srgbClr val="EAE5DD"/>
             </a:solidFill>
           </a:ln>
-          <a:effectLst/>
-        </p:spPr>
-        <p:style>
-          <a:lnRef idx="1">
-            <a:schemeClr val="accent1"/>
-          </a:lnRef>
-          <a:fillRef idx="3">
-            <a:schemeClr val="accent1"/>
-          </a:fillRef>
-          <a:effectRef idx="2">
-            <a:schemeClr val="accent1"/>
-          </a:effectRef>
-          <a:fontRef idx="minor">
-            <a:schemeClr val="lt1"/>
-          </a:fontRef>
-        </p:style>
+        </p:spPr>
         <p:txBody>
           <a:bodyPr rtlCol="0" anchor="ctr"/>
           <a:lstStyle/>
@@ -7549,22 +7078,7 @@
           <a:ln>
             <a:noFill/>
           </a:ln>
-          <a:effectLst/>
-        </p:spPr>
-        <p:style>
-          <a:lnRef idx="1">
-            <a:schemeClr val="accent1"/>
-          </a:lnRef>
-          <a:fillRef idx="3">
-            <a:schemeClr val="accent1"/>
-          </a:fillRef>
-          <a:effectRef idx="2">
-            <a:schemeClr val="accent1"/>
-          </a:effectRef>
-          <a:fontRef idx="minor">
-            <a:schemeClr val="lt1"/>
-          </a:fontRef>
-        </p:style>
+        </p:spPr>
         <p:txBody>
           <a:bodyPr rtlCol="0" anchor="ctr"/>
           <a:lstStyle/>
@@ -7688,22 +7202,7 @@
               <a:srgbClr val="EAE5DD"/>
             </a:solidFill>
           </a:ln>
-          <a:effectLst/>
-        </p:spPr>
-        <p:style>
-          <a:lnRef idx="1">
-            <a:schemeClr val="accent1"/>
-          </a:lnRef>
-          <a:fillRef idx="3">
-            <a:schemeClr val="accent1"/>
-          </a:fillRef>
-          <a:effectRef idx="2">
-            <a:schemeClr val="accent1"/>
-          </a:effectRef>
-          <a:fontRef idx="minor">
-            <a:schemeClr val="lt1"/>
-          </a:fontRef>
-        </p:style>
+        </p:spPr>
         <p:txBody>
           <a:bodyPr rtlCol="0" anchor="ctr"/>
           <a:lstStyle/>
@@ -7732,22 +7231,7 @@
           <a:ln>
             <a:noFill/>
           </a:ln>
-          <a:effectLst/>
-        </p:spPr>
-        <p:style>
-          <a:lnRef idx="1">
-            <a:schemeClr val="accent1"/>
-          </a:lnRef>
-          <a:fillRef idx="3">
-            <a:schemeClr val="accent1"/>
-          </a:fillRef>
-          <a:effectRef idx="2">
-            <a:schemeClr val="accent1"/>
-          </a:effectRef>
-          <a:fontRef idx="minor">
-            <a:schemeClr val="lt1"/>
-          </a:fontRef>
-        </p:style>
+        </p:spPr>
         <p:txBody>
           <a:bodyPr rtlCol="0" anchor="ctr"/>
           <a:lstStyle/>
@@ -7846,22 +7330,7 @@
               <a:srgbClr val="EAE5DD"/>
             </a:solidFill>
           </a:ln>
-          <a:effectLst/>
-        </p:spPr>
-        <p:style>
-          <a:lnRef idx="1">
-            <a:schemeClr val="accent1"/>
-          </a:lnRef>
-          <a:fillRef idx="3">
-            <a:schemeClr val="accent1"/>
-          </a:fillRef>
-          <a:effectRef idx="2">
-            <a:schemeClr val="accent1"/>
-          </a:effectRef>
-          <a:fontRef idx="minor">
-            <a:schemeClr val="lt1"/>
-          </a:fontRef>
-        </p:style>
+        </p:spPr>
         <p:txBody>
           <a:bodyPr rtlCol="0" anchor="ctr"/>
           <a:lstStyle/>
@@ -7890,22 +7359,7 @@
           <a:ln>
             <a:noFill/>
           </a:ln>
-          <a:effectLst/>
-        </p:spPr>
-        <p:style>
-          <a:lnRef idx="1">
-            <a:schemeClr val="accent1"/>
-          </a:lnRef>
-          <a:fillRef idx="3">
-            <a:schemeClr val="accent1"/>
-          </a:fillRef>
-          <a:effectRef idx="2">
-            <a:schemeClr val="accent1"/>
-          </a:effectRef>
-          <a:fontRef idx="minor">
-            <a:schemeClr val="lt1"/>
-          </a:fontRef>
-        </p:style>
+        </p:spPr>
         <p:txBody>
           <a:bodyPr rtlCol="0" anchor="ctr"/>
           <a:lstStyle/>
@@ -8150,22 +7604,7 @@
               <a:srgbClr val="EAE5DD"/>
             </a:solidFill>
           </a:ln>
-          <a:effectLst/>
-        </p:spPr>
-        <p:style>
-          <a:lnRef idx="1">
-            <a:schemeClr val="accent1"/>
-          </a:lnRef>
-          <a:fillRef idx="3">
-            <a:schemeClr val="accent1"/>
-          </a:fillRef>
-          <a:effectRef idx="2">
-            <a:schemeClr val="accent1"/>
-          </a:effectRef>
-          <a:fontRef idx="minor">
-            <a:schemeClr val="lt1"/>
-          </a:fontRef>
-        </p:style>
+        </p:spPr>
         <p:txBody>
           <a:bodyPr rtlCol="0" anchor="ctr"/>
           <a:lstStyle/>
@@ -8248,22 +7687,7 @@
               <a:srgbClr val="EAE5DD"/>
             </a:solidFill>
           </a:ln>
-          <a:effectLst/>
-        </p:spPr>
-        <p:style>
-          <a:lnRef idx="1">
-            <a:schemeClr val="accent1"/>
-          </a:lnRef>
-          <a:fillRef idx="3">
-            <a:schemeClr val="accent1"/>
-          </a:fillRef>
-          <a:effectRef idx="2">
-            <a:schemeClr val="accent1"/>
-          </a:effectRef>
-          <a:fontRef idx="minor">
-            <a:schemeClr val="lt1"/>
-          </a:fontRef>
-        </p:style>
+        </p:spPr>
         <p:txBody>
           <a:bodyPr rtlCol="0" anchor="ctr"/>
           <a:lstStyle/>
@@ -8346,22 +7770,7 @@
               <a:srgbClr val="EAE5DD"/>
             </a:solidFill>
           </a:ln>
-          <a:effectLst/>
-        </p:spPr>
-        <p:style>
-          <a:lnRef idx="1">
-            <a:schemeClr val="accent1"/>
-          </a:lnRef>
-          <a:fillRef idx="3">
-            <a:schemeClr val="accent1"/>
-          </a:fillRef>
-          <a:effectRef idx="2">
-            <a:schemeClr val="accent1"/>
-          </a:effectRef>
-          <a:fontRef idx="minor">
-            <a:schemeClr val="lt1"/>
-          </a:fontRef>
-        </p:style>
+        </p:spPr>
         <p:txBody>
           <a:bodyPr rtlCol="0" anchor="ctr"/>
           <a:lstStyle/>
@@ -8460,22 +7869,7 @@
               <a:srgbClr val="EAE5DD"/>
             </a:solidFill>
           </a:ln>
-          <a:effectLst/>
-        </p:spPr>
-        <p:style>
-          <a:lnRef idx="1">
-            <a:schemeClr val="accent1"/>
-          </a:lnRef>
-          <a:fillRef idx="3">
-            <a:schemeClr val="accent1"/>
-          </a:fillRef>
-          <a:effectRef idx="2">
-            <a:schemeClr val="accent1"/>
-          </a:effectRef>
-          <a:fontRef idx="minor">
-            <a:schemeClr val="lt1"/>
-          </a:fontRef>
-        </p:style>
+        </p:spPr>
         <p:txBody>
           <a:bodyPr rtlCol="0" anchor="ctr"/>
           <a:lstStyle/>
@@ -8574,22 +7968,7 @@
               <a:srgbClr val="EAE5DD"/>
             </a:solidFill>
           </a:ln>
-          <a:effectLst/>
-        </p:spPr>
-        <p:style>
-          <a:lnRef idx="1">
-            <a:schemeClr val="accent1"/>
-          </a:lnRef>
-          <a:fillRef idx="3">
-            <a:schemeClr val="accent1"/>
-          </a:fillRef>
-          <a:effectRef idx="2">
-            <a:schemeClr val="accent1"/>
-          </a:effectRef>
-          <a:fontRef idx="minor">
-            <a:schemeClr val="lt1"/>
-          </a:fontRef>
-        </p:style>
+        </p:spPr>
         <p:txBody>
           <a:bodyPr rtlCol="0" anchor="ctr"/>
           <a:lstStyle/>
@@ -8688,22 +8067,7 @@
               <a:srgbClr val="EAE5DD"/>
             </a:solidFill>
           </a:ln>
-          <a:effectLst/>
-        </p:spPr>
-        <p:style>
-          <a:lnRef idx="1">
-            <a:schemeClr val="accent1"/>
-          </a:lnRef>
-          <a:fillRef idx="3">
-            <a:schemeClr val="accent1"/>
-          </a:fillRef>
-          <a:effectRef idx="2">
-            <a:schemeClr val="accent1"/>
-          </a:effectRef>
-          <a:fontRef idx="minor">
-            <a:schemeClr val="lt1"/>
-          </a:fontRef>
-        </p:style>
+        </p:spPr>
         <p:txBody>
           <a:bodyPr rtlCol="0" anchor="ctr"/>
           <a:lstStyle/>
@@ -8770,22 +8134,7 @@
               <a:srgbClr val="EAE5DD"/>
             </a:solidFill>
           </a:ln>
-          <a:effectLst/>
-        </p:spPr>
-        <p:style>
-          <a:lnRef idx="1">
-            <a:schemeClr val="accent1"/>
-          </a:lnRef>
-          <a:fillRef idx="3">
-            <a:schemeClr val="accent1"/>
-          </a:fillRef>
-          <a:effectRef idx="2">
-            <a:schemeClr val="accent1"/>
-          </a:effectRef>
-          <a:fontRef idx="minor">
-            <a:schemeClr val="lt1"/>
-          </a:fontRef>
-        </p:style>
+        </p:spPr>
         <p:txBody>
           <a:bodyPr rtlCol="0" anchor="ctr"/>
           <a:lstStyle/>
@@ -8920,22 +8269,7 @@
               <a:srgbClr val="EAE5DD"/>
             </a:solidFill>
           </a:ln>
-          <a:effectLst/>
-        </p:spPr>
-        <p:style>
-          <a:lnRef idx="1">
-            <a:schemeClr val="accent1"/>
-          </a:lnRef>
-          <a:fillRef idx="3">
-            <a:schemeClr val="accent1"/>
-          </a:fillRef>
-          <a:effectRef idx="2">
-            <a:schemeClr val="accent1"/>
-          </a:effectRef>
-          <a:fontRef idx="minor">
-            <a:schemeClr val="lt1"/>
-          </a:fontRef>
-        </p:style>
+        </p:spPr>
         <p:txBody>
           <a:bodyPr rtlCol="0" anchor="ctr"/>
           <a:lstStyle/>
@@ -9070,22 +8404,7 @@
               <a:srgbClr val="EAE5DD"/>
             </a:solidFill>
           </a:ln>
-          <a:effectLst/>
-        </p:spPr>
-        <p:style>
-          <a:lnRef idx="1">
-            <a:schemeClr val="accent1"/>
-          </a:lnRef>
-          <a:fillRef idx="3">
-            <a:schemeClr val="accent1"/>
-          </a:fillRef>
-          <a:effectRef idx="2">
-            <a:schemeClr val="accent1"/>
-          </a:effectRef>
-          <a:fontRef idx="minor">
-            <a:schemeClr val="lt1"/>
-          </a:fontRef>
-        </p:style>
+        </p:spPr>
         <p:txBody>
           <a:bodyPr rtlCol="0" anchor="ctr"/>
           <a:lstStyle/>
@@ -9220,22 +8539,7 @@
               <a:srgbClr val="C5523A"/>
             </a:solidFill>
           </a:ln>
-          <a:effectLst/>
-        </p:spPr>
-        <p:style>
-          <a:lnRef idx="1">
-            <a:schemeClr val="accent1"/>
-          </a:lnRef>
-          <a:fillRef idx="3">
-            <a:schemeClr val="accent1"/>
-          </a:fillRef>
-          <a:effectRef idx="2">
-            <a:schemeClr val="accent1"/>
-          </a:effectRef>
-          <a:fontRef idx="minor">
-            <a:schemeClr val="lt1"/>
-          </a:fontRef>
-        </p:style>
+        </p:spPr>
         <p:txBody>
           <a:bodyPr rtlCol="0" anchor="ctr"/>
           <a:lstStyle/>
@@ -9370,22 +8674,7 @@
               <a:srgbClr val="EAE5DD"/>
             </a:solidFill>
           </a:ln>
-          <a:effectLst/>
-        </p:spPr>
-        <p:style>
-          <a:lnRef idx="1">
-            <a:schemeClr val="accent1"/>
-          </a:lnRef>
-          <a:fillRef idx="3">
-            <a:schemeClr val="accent1"/>
-          </a:fillRef>
-          <a:effectRef idx="2">
-            <a:schemeClr val="accent1"/>
-          </a:effectRef>
-          <a:fontRef idx="minor">
-            <a:schemeClr val="lt1"/>
-          </a:fontRef>
-        </p:style>
+        </p:spPr>
         <p:txBody>
           <a:bodyPr rtlCol="0" anchor="ctr"/>
           <a:lstStyle/>
@@ -9683,22 +8972,7 @@
               <a:srgbClr val="EAE5DD"/>
             </a:solidFill>
           </a:ln>
-          <a:effectLst/>
-        </p:spPr>
-        <p:style>
-          <a:lnRef idx="1">
-            <a:schemeClr val="accent1"/>
-          </a:lnRef>
-          <a:fillRef idx="3">
-            <a:schemeClr val="accent1"/>
-          </a:fillRef>
-          <a:effectRef idx="2">
-            <a:schemeClr val="accent1"/>
-          </a:effectRef>
-          <a:fontRef idx="minor">
-            <a:schemeClr val="lt1"/>
-          </a:fontRef>
-        </p:style>
+        </p:spPr>
         <p:txBody>
           <a:bodyPr rtlCol="0" anchor="ctr"/>
           <a:lstStyle/>
@@ -9707,76 +8981,64 @@
           </a:p>
         </p:txBody>
       </p:sp>
-      <p:cxnSp>
-        <p:nvCxnSpPr>
-          <p:cNvPr id="4" name="Connector 3"/>
-          <p:cNvCxnSpPr/>
-          <p:nvPr/>
-        </p:nvCxnSpPr>
-        <p:spPr>
-          <a:xfrm>
-            <a:off x="1005840" y="5806440"/>
-            <a:ext cx="6035040" cy="0"/>
-          </a:xfrm>
-          <a:prstGeom prst="line">
-            <a:avLst/>
-          </a:prstGeom>
-          <a:ln w="12700">
-            <a:solidFill>
-              <a:srgbClr val="A39BA8"/>
-            </a:solidFill>
+      <p:sp>
+        <p:nvSpPr>
+          <p:cNvPr id="4" name="Rectangle 3"/>
+          <p:cNvSpPr/>
+          <p:nvPr/>
+        </p:nvSpPr>
+        <p:spPr>
+          <a:xfrm>
+            <a:off x="1005840" y="5800090"/>
+            <a:ext cx="6035040" cy="12700"/>
+          </a:xfrm>
+          <a:prstGeom prst="rect">
+            <a:avLst/>
+          </a:prstGeom>
+          <a:solidFill>
+            <a:srgbClr val="A39BA8"/>
+          </a:solidFill>
+          <a:ln>
+            <a:noFill/>
           </a:ln>
         </p:spPr>
-        <p:style>
-          <a:lnRef idx="2">
-            <a:schemeClr val="accent1"/>
-          </a:lnRef>
-          <a:fillRef idx="0">
-            <a:schemeClr val="accent1"/>
-          </a:fillRef>
-          <a:effectRef idx="1">
-            <a:schemeClr val="accent1"/>
-          </a:effectRef>
-          <a:fontRef idx="minor">
-            <a:schemeClr val="tx1"/>
-          </a:fontRef>
-        </p:style>
-      </p:cxnSp>
-      <p:cxnSp>
-        <p:nvCxnSpPr>
-          <p:cNvPr id="5" name="Connector 4"/>
-          <p:cNvCxnSpPr/>
-          <p:nvPr/>
-        </p:nvCxnSpPr>
-        <p:spPr>
-          <a:xfrm>
-            <a:off x="1005840" y="2286000"/>
-            <a:ext cx="0" cy="3520440"/>
-          </a:xfrm>
-          <a:prstGeom prst="line">
-            <a:avLst/>
-          </a:prstGeom>
-          <a:ln w="12700">
-            <a:solidFill>
-              <a:srgbClr val="A39BA8"/>
-            </a:solidFill>
+        <p:txBody>
+          <a:bodyPr rtlCol="0" anchor="ctr"/>
+          <a:lstStyle/>
+          <a:p>
+            <a:pPr algn="ctr"/>
+          </a:p>
+        </p:txBody>
+      </p:sp>
+      <p:sp>
+        <p:nvSpPr>
+          <p:cNvPr id="5" name="Rectangle 4"/>
+          <p:cNvSpPr/>
+          <p:nvPr/>
+        </p:nvSpPr>
+        <p:spPr>
+          <a:xfrm>
+            <a:off x="999490" y="2286000"/>
+            <a:ext cx="12700" cy="3520440"/>
+          </a:xfrm>
+          <a:prstGeom prst="rect">
+            <a:avLst/>
+          </a:prstGeom>
+          <a:solidFill>
+            <a:srgbClr val="A39BA8"/>
+          </a:solidFill>
+          <a:ln>
+            <a:noFill/>
           </a:ln>
         </p:spPr>
-        <p:style>
-          <a:lnRef idx="2">
-            <a:schemeClr val="accent1"/>
-          </a:lnRef>
-          <a:fillRef idx="0">
-            <a:schemeClr val="accent1"/>
-          </a:fillRef>
-          <a:effectRef idx="1">
-            <a:schemeClr val="accent1"/>
-          </a:effectRef>
-          <a:fontRef idx="minor">
-            <a:schemeClr val="tx1"/>
-          </a:fontRef>
-        </p:style>
-      </p:cxnSp>
+        <p:txBody>
+          <a:bodyPr rtlCol="0" anchor="ctr"/>
+          <a:lstStyle/>
+          <a:p>
+            <a:pPr algn="ctr"/>
+          </a:p>
+        </p:txBody>
+      </p:sp>
       <p:sp>
         <p:nvSpPr>
           <p:cNvPr id="6" name="TextBox 5"/>
@@ -9882,78 +9144,64 @@
           </a:p>
         </p:txBody>
       </p:sp>
-      <p:cxnSp>
-        <p:nvCxnSpPr>
-          <p:cNvPr id="9" name="Connector 8"/>
-          <p:cNvCxnSpPr/>
-          <p:nvPr/>
-        </p:nvCxnSpPr>
-        <p:spPr>
-          <a:xfrm>
-            <a:off x="4023360.0" y="2286000"/>
-            <a:ext cx="0.0" cy="3520440"/>
-          </a:xfrm>
-          <a:prstGeom prst="line">
-            <a:avLst/>
-          </a:prstGeom>
-          <a:ln w="6350">
-            <a:solidFill>
-              <a:srgbClr val="EAE5DD"/>
-            </a:solidFill>
-            <a:prstDash val="lgDash"/>
+      <p:sp>
+        <p:nvSpPr>
+          <p:cNvPr id="9" name="Rectangle 8"/>
+          <p:cNvSpPr/>
+          <p:nvPr/>
+        </p:nvSpPr>
+        <p:spPr>
+          <a:xfrm>
+            <a:off x="4020185" y="2286000"/>
+            <a:ext cx="6350" cy="3520440"/>
+          </a:xfrm>
+          <a:prstGeom prst="rect">
+            <a:avLst/>
+          </a:prstGeom>
+          <a:solidFill>
+            <a:srgbClr val="EAE5DD"/>
+          </a:solidFill>
+          <a:ln>
+            <a:noFill/>
           </a:ln>
         </p:spPr>
-        <p:style>
-          <a:lnRef idx="2">
-            <a:schemeClr val="accent1"/>
-          </a:lnRef>
-          <a:fillRef idx="0">
-            <a:schemeClr val="accent1"/>
-          </a:fillRef>
-          <a:effectRef idx="1">
-            <a:schemeClr val="accent1"/>
-          </a:effectRef>
-          <a:fontRef idx="minor">
-            <a:schemeClr val="tx1"/>
-          </a:fontRef>
-        </p:style>
-      </p:cxnSp>
-      <p:cxnSp>
-        <p:nvCxnSpPr>
-          <p:cNvPr id="10" name="Connector 9"/>
-          <p:cNvCxnSpPr/>
-          <p:nvPr/>
-        </p:nvCxnSpPr>
-        <p:spPr>
-          <a:xfrm>
-            <a:off x="1005840" y="4046220.0"/>
-            <a:ext cx="6035040" cy="0.0"/>
-          </a:xfrm>
-          <a:prstGeom prst="line">
-            <a:avLst/>
-          </a:prstGeom>
-          <a:ln w="6350">
-            <a:solidFill>
-              <a:srgbClr val="EAE5DD"/>
-            </a:solidFill>
-            <a:prstDash val="lgDash"/>
+        <p:txBody>
+          <a:bodyPr rtlCol="0" anchor="ctr"/>
+          <a:lstStyle/>
+          <a:p>
+            <a:pPr algn="ctr"/>
+          </a:p>
+        </p:txBody>
+      </p:sp>
+      <p:sp>
+        <p:nvSpPr>
+          <p:cNvPr id="10" name="Rectangle 9"/>
+          <p:cNvSpPr/>
+          <p:nvPr/>
+        </p:nvSpPr>
+        <p:spPr>
+          <a:xfrm>
+            <a:off x="1005840" y="4043045"/>
+            <a:ext cx="6035040" cy="6350"/>
+          </a:xfrm>
+          <a:prstGeom prst="rect">
+            <a:avLst/>
+          </a:prstGeom>
+          <a:solidFill>
+            <a:srgbClr val="EAE5DD"/>
+          </a:solidFill>
+          <a:ln>
+            <a:noFill/>
           </a:ln>
         </p:spPr>
-        <p:style>
-          <a:lnRef idx="2">
-            <a:schemeClr val="accent1"/>
-          </a:lnRef>
-          <a:fillRef idx="0">
-            <a:schemeClr val="accent1"/>
-          </a:fillRef>
-          <a:effectRef idx="1">
-            <a:schemeClr val="accent1"/>
-          </a:effectRef>
-          <a:fontRef idx="minor">
-            <a:schemeClr val="tx1"/>
-          </a:fontRef>
-        </p:style>
-      </p:cxnSp>
+        <p:txBody>
+          <a:bodyPr rtlCol="0" anchor="ctr"/>
+          <a:lstStyle/>
+          <a:p>
+            <a:pPr algn="ctr"/>
+          </a:p>
+        </p:txBody>
+      </p:sp>
       <p:sp>
         <p:nvSpPr>
           <p:cNvPr id="11" name="TextBox 10"/>
@@ -10114,22 +9362,7 @@
           <a:ln>
             <a:noFill/>
           </a:ln>
-          <a:effectLst/>
-        </p:spPr>
-        <p:style>
-          <a:lnRef idx="1">
-            <a:schemeClr val="accent1"/>
-          </a:lnRef>
-          <a:fillRef idx="3">
-            <a:schemeClr val="accent1"/>
-          </a:fillRef>
-          <a:effectRef idx="2">
-            <a:schemeClr val="accent1"/>
-          </a:effectRef>
-          <a:fontRef idx="minor">
-            <a:schemeClr val="lt1"/>
-          </a:fontRef>
-        </p:style>
+        </p:spPr>
         <p:txBody>
           <a:bodyPr rtlCol="0" anchor="ctr"/>
           <a:lstStyle/>
@@ -10192,22 +9425,7 @@
           <a:ln>
             <a:noFill/>
           </a:ln>
-          <a:effectLst/>
-        </p:spPr>
-        <p:style>
-          <a:lnRef idx="1">
-            <a:schemeClr val="accent1"/>
-          </a:lnRef>
-          <a:fillRef idx="3">
-            <a:schemeClr val="accent1"/>
-          </a:fillRef>
-          <a:effectRef idx="2">
-            <a:schemeClr val="accent1"/>
-          </a:effectRef>
-          <a:fontRef idx="minor">
-            <a:schemeClr val="lt1"/>
-          </a:fontRef>
-        </p:style>
+        </p:spPr>
         <p:txBody>
           <a:bodyPr rtlCol="0" anchor="ctr"/>
           <a:lstStyle/>
@@ -10270,22 +9488,7 @@
           <a:ln>
             <a:noFill/>
           </a:ln>
-          <a:effectLst/>
-        </p:spPr>
-        <p:style>
-          <a:lnRef idx="1">
-            <a:schemeClr val="accent1"/>
-          </a:lnRef>
-          <a:fillRef idx="3">
-            <a:schemeClr val="accent1"/>
-          </a:fillRef>
-          <a:effectRef idx="2">
-            <a:schemeClr val="accent1"/>
-          </a:effectRef>
-          <a:fontRef idx="minor">
-            <a:schemeClr val="lt1"/>
-          </a:fontRef>
-        </p:style>
+        </p:spPr>
         <p:txBody>
           <a:bodyPr rtlCol="0" anchor="ctr"/>
           <a:lstStyle/>
@@ -10348,22 +9551,7 @@
           <a:ln>
             <a:noFill/>
           </a:ln>
-          <a:effectLst/>
-        </p:spPr>
-        <p:style>
-          <a:lnRef idx="1">
-            <a:schemeClr val="accent1"/>
-          </a:lnRef>
-          <a:fillRef idx="3">
-            <a:schemeClr val="accent1"/>
-          </a:fillRef>
-          <a:effectRef idx="2">
-            <a:schemeClr val="accent1"/>
-          </a:effectRef>
-          <a:fontRef idx="minor">
-            <a:schemeClr val="lt1"/>
-          </a:fontRef>
-        </p:style>
+        </p:spPr>
         <p:txBody>
           <a:bodyPr rtlCol="0" anchor="ctr"/>
           <a:lstStyle/>
@@ -10426,22 +9614,7 @@
           <a:ln>
             <a:noFill/>
           </a:ln>
-          <a:effectLst/>
-        </p:spPr>
-        <p:style>
-          <a:lnRef idx="1">
-            <a:schemeClr val="accent1"/>
-          </a:lnRef>
-          <a:fillRef idx="3">
-            <a:schemeClr val="accent1"/>
-          </a:fillRef>
-          <a:effectRef idx="2">
-            <a:schemeClr val="accent1"/>
-          </a:effectRef>
-          <a:fontRef idx="minor">
-            <a:schemeClr val="lt1"/>
-          </a:fontRef>
-        </p:style>
+        </p:spPr>
         <p:txBody>
           <a:bodyPr rtlCol="0" anchor="ctr"/>
           <a:lstStyle/>
@@ -10504,22 +9677,7 @@
           <a:ln>
             <a:noFill/>
           </a:ln>
-          <a:effectLst/>
-        </p:spPr>
-        <p:style>
-          <a:lnRef idx="1">
-            <a:schemeClr val="accent1"/>
-          </a:lnRef>
-          <a:fillRef idx="3">
-            <a:schemeClr val="accent1"/>
-          </a:fillRef>
-          <a:effectRef idx="2">
-            <a:schemeClr val="accent1"/>
-          </a:effectRef>
-          <a:fontRef idx="minor">
-            <a:schemeClr val="lt1"/>
-          </a:fontRef>
-        </p:style>
+        </p:spPr>
         <p:txBody>
           <a:bodyPr rtlCol="0" anchor="ctr"/>
           <a:lstStyle/>
@@ -10582,22 +9740,7 @@
           <a:ln>
             <a:noFill/>
           </a:ln>
-          <a:effectLst/>
-        </p:spPr>
-        <p:style>
-          <a:lnRef idx="1">
-            <a:schemeClr val="accent1"/>
-          </a:lnRef>
-          <a:fillRef idx="3">
-            <a:schemeClr val="accent1"/>
-          </a:fillRef>
-          <a:effectRef idx="2">
-            <a:schemeClr val="accent1"/>
-          </a:effectRef>
-          <a:fontRef idx="minor">
-            <a:schemeClr val="lt1"/>
-          </a:fontRef>
-        </p:style>
+        </p:spPr>
         <p:txBody>
           <a:bodyPr rtlCol="0" anchor="ctr"/>
           <a:lstStyle/>
@@ -10660,22 +9803,7 @@
           <a:ln>
             <a:noFill/>
           </a:ln>
-          <a:effectLst/>
-        </p:spPr>
-        <p:style>
-          <a:lnRef idx="1">
-            <a:schemeClr val="accent1"/>
-          </a:lnRef>
-          <a:fillRef idx="3">
-            <a:schemeClr val="accent1"/>
-          </a:fillRef>
-          <a:effectRef idx="2">
-            <a:schemeClr val="accent1"/>
-          </a:effectRef>
-          <a:fontRef idx="minor">
-            <a:schemeClr val="lt1"/>
-          </a:fontRef>
-        </p:style>
+        </p:spPr>
         <p:txBody>
           <a:bodyPr rtlCol="0" anchor="ctr"/>
           <a:lstStyle/>
@@ -10738,22 +9866,7 @@
           <a:ln>
             <a:noFill/>
           </a:ln>
-          <a:effectLst/>
-        </p:spPr>
-        <p:style>
-          <a:lnRef idx="1">
-            <a:schemeClr val="accent1"/>
-          </a:lnRef>
-          <a:fillRef idx="3">
-            <a:schemeClr val="accent1"/>
-          </a:fillRef>
-          <a:effectRef idx="2">
-            <a:schemeClr val="accent1"/>
-          </a:effectRef>
-          <a:fontRef idx="minor">
-            <a:schemeClr val="lt1"/>
-          </a:fontRef>
-        </p:style>
+        </p:spPr>
         <p:txBody>
           <a:bodyPr rtlCol="0" anchor="ctr"/>
           <a:lstStyle/>
@@ -10816,22 +9929,7 @@
           <a:ln>
             <a:noFill/>
           </a:ln>
-          <a:effectLst/>
-        </p:spPr>
-        <p:style>
-          <a:lnRef idx="1">
-            <a:schemeClr val="accent1"/>
-          </a:lnRef>
-          <a:fillRef idx="3">
-            <a:schemeClr val="accent1"/>
-          </a:fillRef>
-          <a:effectRef idx="2">
-            <a:schemeClr val="accent1"/>
-          </a:effectRef>
-          <a:fontRef idx="minor">
-            <a:schemeClr val="lt1"/>
-          </a:fontRef>
-        </p:style>
+        </p:spPr>
         <p:txBody>
           <a:bodyPr rtlCol="0" anchor="ctr"/>
           <a:lstStyle/>
@@ -10894,22 +9992,7 @@
           <a:ln>
             <a:noFill/>
           </a:ln>
-          <a:effectLst/>
-        </p:spPr>
-        <p:style>
-          <a:lnRef idx="1">
-            <a:schemeClr val="accent1"/>
-          </a:lnRef>
-          <a:fillRef idx="3">
-            <a:schemeClr val="accent1"/>
-          </a:fillRef>
-          <a:effectRef idx="2">
-            <a:schemeClr val="accent1"/>
-          </a:effectRef>
-          <a:fontRef idx="minor">
-            <a:schemeClr val="lt1"/>
-          </a:fontRef>
-        </p:style>
+        </p:spPr>
         <p:txBody>
           <a:bodyPr rtlCol="0" anchor="ctr"/>
           <a:lstStyle/>
@@ -10972,22 +10055,7 @@
           <a:ln>
             <a:noFill/>
           </a:ln>
-          <a:effectLst/>
-        </p:spPr>
-        <p:style>
-          <a:lnRef idx="1">
-            <a:schemeClr val="accent1"/>
-          </a:lnRef>
-          <a:fillRef idx="3">
-            <a:schemeClr val="accent1"/>
-          </a:fillRef>
-          <a:effectRef idx="2">
-            <a:schemeClr val="accent1"/>
-          </a:effectRef>
-          <a:fontRef idx="minor">
-            <a:schemeClr val="lt1"/>
-          </a:fontRef>
-        </p:style>
+        </p:spPr>
         <p:txBody>
           <a:bodyPr rtlCol="0" anchor="ctr"/>
           <a:lstStyle/>
@@ -11016,22 +10084,7 @@
           <a:ln>
             <a:noFill/>
           </a:ln>
-          <a:effectLst/>
-        </p:spPr>
-        <p:style>
-          <a:lnRef idx="1">
-            <a:schemeClr val="accent1"/>
-          </a:lnRef>
-          <a:fillRef idx="3">
-            <a:schemeClr val="accent1"/>
-          </a:fillRef>
-          <a:effectRef idx="2">
-            <a:schemeClr val="accent1"/>
-          </a:effectRef>
-          <a:fontRef idx="minor">
-            <a:schemeClr val="lt1"/>
-          </a:fontRef>
-        </p:style>
+        </p:spPr>
         <p:txBody>
           <a:bodyPr rtlCol="0" anchor="ctr"/>
           <a:lstStyle/>
@@ -11060,22 +10113,7 @@
           <a:ln>
             <a:noFill/>
           </a:ln>
-          <a:effectLst/>
-        </p:spPr>
-        <p:style>
-          <a:lnRef idx="1">
-            <a:schemeClr val="accent1"/>
-          </a:lnRef>
-          <a:fillRef idx="3">
-            <a:schemeClr val="accent1"/>
-          </a:fillRef>
-          <a:effectRef idx="2">
-            <a:schemeClr val="accent1"/>
-          </a:effectRef>
-          <a:fontRef idx="minor">
-            <a:schemeClr val="lt1"/>
-          </a:fontRef>
-        </p:style>
+        </p:spPr>
         <p:txBody>
           <a:bodyPr rtlCol="0" anchor="ctr"/>
           <a:lstStyle/>
@@ -11474,22 +10512,7 @@
               <a:srgbClr val="EAE5DD"/>
             </a:solidFill>
           </a:ln>
-          <a:effectLst/>
-        </p:spPr>
-        <p:style>
-          <a:lnRef idx="1">
-            <a:schemeClr val="accent1"/>
-          </a:lnRef>
-          <a:fillRef idx="3">
-            <a:schemeClr val="accent1"/>
-          </a:fillRef>
-          <a:effectRef idx="2">
-            <a:schemeClr val="accent1"/>
-          </a:effectRef>
-          <a:fontRef idx="minor">
-            <a:schemeClr val="lt1"/>
-          </a:fontRef>
-        </p:style>
+        </p:spPr>
         <p:txBody>
           <a:bodyPr rtlCol="0" anchor="ctr"/>
           <a:lstStyle/>
@@ -11518,22 +10541,7 @@
           <a:ln>
             <a:noFill/>
           </a:ln>
-          <a:effectLst/>
-        </p:spPr>
-        <p:style>
-          <a:lnRef idx="1">
-            <a:schemeClr val="accent1"/>
-          </a:lnRef>
-          <a:fillRef idx="3">
-            <a:schemeClr val="accent1"/>
-          </a:fillRef>
-          <a:effectRef idx="2">
-            <a:schemeClr val="accent1"/>
-          </a:effectRef>
-          <a:fontRef idx="minor">
-            <a:schemeClr val="lt1"/>
-          </a:fontRef>
-        </p:style>
+        </p:spPr>
         <p:txBody>
           <a:bodyPr rtlCol="0" anchor="ctr"/>
           <a:lstStyle/>
@@ -11682,22 +10690,7 @@
               <a:srgbClr val="EAE5DD"/>
             </a:solidFill>
           </a:ln>
-          <a:effectLst/>
-        </p:spPr>
-        <p:style>
-          <a:lnRef idx="1">
-            <a:schemeClr val="accent1"/>
-          </a:lnRef>
-          <a:fillRef idx="3">
-            <a:schemeClr val="accent1"/>
-          </a:fillRef>
-          <a:effectRef idx="2">
-            <a:schemeClr val="accent1"/>
-          </a:effectRef>
-          <a:fontRef idx="minor">
-            <a:schemeClr val="lt1"/>
-          </a:fontRef>
-        </p:style>
+        </p:spPr>
         <p:txBody>
           <a:bodyPr rtlCol="0" anchor="ctr"/>
           <a:lstStyle/>
@@ -11726,22 +10719,7 @@
           <a:ln>
             <a:noFill/>
           </a:ln>
-          <a:effectLst/>
-        </p:spPr>
-        <p:style>
-          <a:lnRef idx="1">
-            <a:schemeClr val="accent1"/>
-          </a:lnRef>
-          <a:fillRef idx="3">
-            <a:schemeClr val="accent1"/>
-          </a:fillRef>
-          <a:effectRef idx="2">
-            <a:schemeClr val="accent1"/>
-          </a:effectRef>
-          <a:fontRef idx="minor">
-            <a:schemeClr val="lt1"/>
-          </a:fontRef>
-        </p:style>
+        </p:spPr>
         <p:txBody>
           <a:bodyPr rtlCol="0" anchor="ctr"/>
           <a:lstStyle/>
@@ -11890,22 +10868,7 @@
               <a:srgbClr val="EAE5DD"/>
             </a:solidFill>
           </a:ln>
-          <a:effectLst/>
-        </p:spPr>
-        <p:style>
-          <a:lnRef idx="1">
-            <a:schemeClr val="accent1"/>
-          </a:lnRef>
-          <a:fillRef idx="3">
-            <a:schemeClr val="accent1"/>
-          </a:fillRef>
-          <a:effectRef idx="2">
-            <a:schemeClr val="accent1"/>
-          </a:effectRef>
-          <a:fontRef idx="minor">
-            <a:schemeClr val="lt1"/>
-          </a:fontRef>
-        </p:style>
+        </p:spPr>
         <p:txBody>
           <a:bodyPr rtlCol="0" anchor="ctr"/>
           <a:lstStyle/>
@@ -11934,22 +10897,7 @@
           <a:ln>
             <a:noFill/>
           </a:ln>
-          <a:effectLst/>
-        </p:spPr>
-        <p:style>
-          <a:lnRef idx="1">
-            <a:schemeClr val="accent1"/>
-          </a:lnRef>
-          <a:fillRef idx="3">
-            <a:schemeClr val="accent1"/>
-          </a:fillRef>
-          <a:effectRef idx="2">
-            <a:schemeClr val="accent1"/>
-          </a:effectRef>
-          <a:fontRef idx="minor">
-            <a:schemeClr val="lt1"/>
-          </a:fontRef>
-        </p:style>
+        </p:spPr>
         <p:txBody>
           <a:bodyPr rtlCol="0" anchor="ctr"/>
           <a:lstStyle/>
@@ -12219,22 +11167,7 @@
               <a:srgbClr val="EAE5DD"/>
             </a:solidFill>
           </a:ln>
-          <a:effectLst/>
-        </p:spPr>
-        <p:style>
-          <a:lnRef idx="1">
-            <a:schemeClr val="accent1"/>
-          </a:lnRef>
-          <a:fillRef idx="3">
-            <a:schemeClr val="accent1"/>
-          </a:fillRef>
-          <a:effectRef idx="2">
-            <a:schemeClr val="accent1"/>
-          </a:effectRef>
-          <a:fontRef idx="minor">
-            <a:schemeClr val="lt1"/>
-          </a:fontRef>
-        </p:style>
+        </p:spPr>
         <p:txBody>
           <a:bodyPr rtlCol="0" anchor="ctr"/>
           <a:lstStyle/>
@@ -12263,22 +11196,7 @@
           <a:ln>
             <a:noFill/>
           </a:ln>
-          <a:effectLst/>
-        </p:spPr>
-        <p:style>
-          <a:lnRef idx="1">
-            <a:schemeClr val="accent1"/>
-          </a:lnRef>
-          <a:fillRef idx="3">
-            <a:schemeClr val="accent1"/>
-          </a:fillRef>
-          <a:effectRef idx="2">
-            <a:schemeClr val="accent1"/>
-          </a:effectRef>
-          <a:fontRef idx="minor">
-            <a:schemeClr val="lt1"/>
-          </a:fontRef>
-        </p:style>
+        </p:spPr>
         <p:txBody>
           <a:bodyPr rtlCol="0" anchor="ctr"/>
           <a:lstStyle/>
@@ -12379,22 +11297,7 @@
               <a:srgbClr val="EAE5DD"/>
             </a:solidFill>
           </a:ln>
-          <a:effectLst/>
-        </p:spPr>
-        <p:style>
-          <a:lnRef idx="1">
-            <a:schemeClr val="accent1"/>
-          </a:lnRef>
-          <a:fillRef idx="3">
-            <a:schemeClr val="accent1"/>
-          </a:fillRef>
-          <a:effectRef idx="2">
-            <a:schemeClr val="accent1"/>
-          </a:effectRef>
-          <a:fontRef idx="minor">
-            <a:schemeClr val="lt1"/>
-          </a:fontRef>
-        </p:style>
+        </p:spPr>
         <p:txBody>
           <a:bodyPr rtlCol="0" anchor="ctr"/>
           <a:lstStyle/>
@@ -12777,22 +11680,7 @@
               <a:srgbClr val="EAE5DD"/>
             </a:solidFill>
           </a:ln>
-          <a:effectLst/>
-        </p:spPr>
-        <p:style>
-          <a:lnRef idx="1">
-            <a:schemeClr val="accent1"/>
-          </a:lnRef>
-          <a:fillRef idx="3">
-            <a:schemeClr val="accent1"/>
-          </a:fillRef>
-          <a:effectRef idx="2">
-            <a:schemeClr val="accent1"/>
-          </a:effectRef>
-          <a:fontRef idx="minor">
-            <a:schemeClr val="lt1"/>
-          </a:fontRef>
-        </p:style>
+        </p:spPr>
         <p:txBody>
           <a:bodyPr rtlCol="0" anchor="ctr"/>
           <a:lstStyle/>
@@ -13029,22 +11917,7 @@
               <a:srgbClr val="EAE5DD"/>
             </a:solidFill>
           </a:ln>
-          <a:effectLst/>
-        </p:spPr>
-        <p:style>
-          <a:lnRef idx="1">
-            <a:schemeClr val="accent1"/>
-          </a:lnRef>
-          <a:fillRef idx="3">
-            <a:schemeClr val="accent1"/>
-          </a:fillRef>
-          <a:effectRef idx="2">
-            <a:schemeClr val="accent1"/>
-          </a:effectRef>
-          <a:fontRef idx="minor">
-            <a:schemeClr val="lt1"/>
-          </a:fontRef>
-        </p:style>
+        </p:spPr>
         <p:txBody>
           <a:bodyPr rtlCol="0" anchor="ctr"/>
           <a:lstStyle/>
@@ -13112,22 +11985,7 @@
               <a:srgbClr val="EAE5DD"/>
             </a:solidFill>
           </a:ln>
-          <a:effectLst/>
-        </p:spPr>
-        <p:style>
-          <a:lnRef idx="1">
-            <a:schemeClr val="accent1"/>
-          </a:lnRef>
-          <a:fillRef idx="3">
-            <a:schemeClr val="accent1"/>
-          </a:fillRef>
-          <a:effectRef idx="2">
-            <a:schemeClr val="accent1"/>
-          </a:effectRef>
-          <a:fontRef idx="minor">
-            <a:schemeClr val="lt1"/>
-          </a:fontRef>
-        </p:style>
+        </p:spPr>
         <p:txBody>
           <a:bodyPr rtlCol="0" anchor="ctr"/>
           <a:lstStyle/>
@@ -13226,22 +12084,7 @@
               <a:srgbClr val="EAE5DD"/>
             </a:solidFill>
           </a:ln>
-          <a:effectLst/>
-        </p:spPr>
-        <p:style>
-          <a:lnRef idx="1">
-            <a:schemeClr val="accent1"/>
-          </a:lnRef>
-          <a:fillRef idx="3">
-            <a:schemeClr val="accent1"/>
-          </a:fillRef>
-          <a:effectRef idx="2">
-            <a:schemeClr val="accent1"/>
-          </a:effectRef>
-          <a:fontRef idx="minor">
-            <a:schemeClr val="lt1"/>
-          </a:fontRef>
-        </p:style>
+        </p:spPr>
         <p:txBody>
           <a:bodyPr rtlCol="0" anchor="ctr"/>
           <a:lstStyle/>
@@ -13340,22 +12183,7 @@
               <a:srgbClr val="EAE5DD"/>
             </a:solidFill>
           </a:ln>
-          <a:effectLst/>
-        </p:spPr>
-        <p:style>
-          <a:lnRef idx="1">
-            <a:schemeClr val="accent1"/>
-          </a:lnRef>
-          <a:fillRef idx="3">
-            <a:schemeClr val="accent1"/>
-          </a:fillRef>
-          <a:effectRef idx="2">
-            <a:schemeClr val="accent1"/>
-          </a:effectRef>
-          <a:fontRef idx="minor">
-            <a:schemeClr val="lt1"/>
-          </a:fontRef>
-        </p:style>
+        </p:spPr>
         <p:txBody>
           <a:bodyPr rtlCol="0" anchor="ctr"/>
           <a:lstStyle/>
@@ -13454,22 +12282,7 @@
               <a:srgbClr val="EAE5DD"/>
             </a:solidFill>
           </a:ln>
-          <a:effectLst/>
-        </p:spPr>
-        <p:style>
-          <a:lnRef idx="1">
-            <a:schemeClr val="accent1"/>
-          </a:lnRef>
-          <a:fillRef idx="3">
-            <a:schemeClr val="accent1"/>
-          </a:fillRef>
-          <a:effectRef idx="2">
-            <a:schemeClr val="accent1"/>
-          </a:effectRef>
-          <a:fontRef idx="minor">
-            <a:schemeClr val="lt1"/>
-          </a:fontRef>
-        </p:style>
+        </p:spPr>
         <p:txBody>
           <a:bodyPr rtlCol="0" anchor="ctr"/>
           <a:lstStyle/>
@@ -13568,22 +12381,7 @@
               <a:srgbClr val="EAE5DD"/>
             </a:solidFill>
           </a:ln>
-          <a:effectLst/>
-        </p:spPr>
-        <p:style>
-          <a:lnRef idx="1">
-            <a:schemeClr val="accent1"/>
-          </a:lnRef>
-          <a:fillRef idx="3">
-            <a:schemeClr val="accent1"/>
-          </a:fillRef>
-          <a:effectRef idx="2">
-            <a:schemeClr val="accent1"/>
-          </a:effectRef>
-          <a:fontRef idx="minor">
-            <a:schemeClr val="lt1"/>
-          </a:fontRef>
-        </p:style>
+        </p:spPr>
         <p:txBody>
           <a:bodyPr rtlCol="0" anchor="ctr"/>
           <a:lstStyle/>
@@ -13682,22 +12480,7 @@
               <a:srgbClr val="EAE5DD"/>
             </a:solidFill>
           </a:ln>
-          <a:effectLst/>
-        </p:spPr>
-        <p:style>
-          <a:lnRef idx="1">
-            <a:schemeClr val="accent1"/>
-          </a:lnRef>
-          <a:fillRef idx="3">
-            <a:schemeClr val="accent1"/>
-          </a:fillRef>
-          <a:effectRef idx="2">
-            <a:schemeClr val="accent1"/>
-          </a:effectRef>
-          <a:fontRef idx="minor">
-            <a:schemeClr val="lt1"/>
-          </a:fontRef>
-        </p:style>
+        </p:spPr>
         <p:txBody>
           <a:bodyPr rtlCol="0" anchor="ctr"/>
           <a:lstStyle/>
@@ -13796,22 +12579,7 @@
               <a:srgbClr val="EAE5DD"/>
             </a:solidFill>
           </a:ln>
-          <a:effectLst/>
-        </p:spPr>
-        <p:style>
-          <a:lnRef idx="1">
-            <a:schemeClr val="accent1"/>
-          </a:lnRef>
-          <a:fillRef idx="3">
-            <a:schemeClr val="accent1"/>
-          </a:fillRef>
-          <a:effectRef idx="2">
-            <a:schemeClr val="accent1"/>
-          </a:effectRef>
-          <a:fontRef idx="minor">
-            <a:schemeClr val="lt1"/>
-          </a:fontRef>
-        </p:style>
+        </p:spPr>
         <p:txBody>
           <a:bodyPr rtlCol="0" anchor="ctr"/>
           <a:lstStyle/>
@@ -13910,22 +12678,7 @@
               <a:srgbClr val="EAE5DD"/>
             </a:solidFill>
           </a:ln>
-          <a:effectLst/>
-        </p:spPr>
-        <p:style>
-          <a:lnRef idx="1">
-            <a:schemeClr val="accent1"/>
-          </a:lnRef>
-          <a:fillRef idx="3">
-            <a:schemeClr val="accent1"/>
-          </a:fillRef>
-          <a:effectRef idx="2">
-            <a:schemeClr val="accent1"/>
-          </a:effectRef>
-          <a:fontRef idx="minor">
-            <a:schemeClr val="lt1"/>
-          </a:fontRef>
-        </p:style>
+        </p:spPr>
         <p:txBody>
           <a:bodyPr rtlCol="0" anchor="ctr"/>
           <a:lstStyle/>
@@ -14170,22 +12923,7 @@
               <a:srgbClr val="EAE5DD"/>
             </a:solidFill>
           </a:ln>
-          <a:effectLst/>
-        </p:spPr>
-        <p:style>
-          <a:lnRef idx="1">
-            <a:schemeClr val="accent1"/>
-          </a:lnRef>
-          <a:fillRef idx="3">
-            <a:schemeClr val="accent1"/>
-          </a:fillRef>
-          <a:effectRef idx="2">
-            <a:schemeClr val="accent1"/>
-          </a:effectRef>
-          <a:fontRef idx="minor">
-            <a:schemeClr val="lt1"/>
-          </a:fontRef>
-        </p:style>
+        </p:spPr>
         <p:txBody>
           <a:bodyPr rtlCol="0" anchor="ctr"/>
           <a:lstStyle/>
@@ -14214,22 +12952,7 @@
           <a:ln>
             <a:noFill/>
           </a:ln>
-          <a:effectLst/>
-        </p:spPr>
-        <p:style>
-          <a:lnRef idx="1">
-            <a:schemeClr val="accent1"/>
-          </a:lnRef>
-          <a:fillRef idx="3">
-            <a:schemeClr val="accent1"/>
-          </a:fillRef>
-          <a:effectRef idx="2">
-            <a:schemeClr val="accent1"/>
-          </a:effectRef>
-          <a:fontRef idx="minor">
-            <a:schemeClr val="lt1"/>
-          </a:fontRef>
-        </p:style>
+        </p:spPr>
         <p:txBody>
           <a:bodyPr rtlCol="0" anchor="ctr"/>
           <a:lstStyle/>
@@ -14344,22 +13067,7 @@
           <a:ln>
             <a:noFill/>
           </a:ln>
-          <a:effectLst/>
-        </p:spPr>
-        <p:style>
-          <a:lnRef idx="1">
-            <a:schemeClr val="accent1"/>
-          </a:lnRef>
-          <a:fillRef idx="3">
-            <a:schemeClr val="accent1"/>
-          </a:fillRef>
-          <a:effectRef idx="2">
-            <a:schemeClr val="accent1"/>
-          </a:effectRef>
-          <a:fontRef idx="minor">
-            <a:schemeClr val="lt1"/>
-          </a:fontRef>
-        </p:style>
+        </p:spPr>
         <p:txBody>
           <a:bodyPr rtlCol="0" anchor="ctr"/>
           <a:lstStyle/>
@@ -14390,22 +13098,7 @@
           <a:ln>
             <a:noFill/>
           </a:ln>
-          <a:effectLst/>
-        </p:spPr>
-        <p:style>
-          <a:lnRef idx="1">
-            <a:schemeClr val="accent1"/>
-          </a:lnRef>
-          <a:fillRef idx="3">
-            <a:schemeClr val="accent1"/>
-          </a:fillRef>
-          <a:effectRef idx="2">
-            <a:schemeClr val="accent1"/>
-          </a:effectRef>
-          <a:fontRef idx="minor">
-            <a:schemeClr val="lt1"/>
-          </a:fontRef>
-        </p:style>
+        </p:spPr>
         <p:txBody>
           <a:bodyPr rtlCol="0" anchor="ctr"/>
           <a:lstStyle/>
@@ -14508,22 +13201,7 @@
               <a:srgbClr val="EAE5DD"/>
             </a:solidFill>
           </a:ln>
-          <a:effectLst/>
-        </p:spPr>
-        <p:style>
-          <a:lnRef idx="1">
-            <a:schemeClr val="accent1"/>
-          </a:lnRef>
-          <a:fillRef idx="3">
-            <a:schemeClr val="accent1"/>
-          </a:fillRef>
-          <a:effectRef idx="2">
-            <a:schemeClr val="accent1"/>
-          </a:effectRef>
-          <a:fontRef idx="minor">
-            <a:schemeClr val="lt1"/>
-          </a:fontRef>
-        </p:style>
+        </p:spPr>
         <p:txBody>
           <a:bodyPr rtlCol="0" anchor="ctr"/>
           <a:lstStyle/>
@@ -14552,22 +13230,7 @@
           <a:ln>
             <a:noFill/>
           </a:ln>
-          <a:effectLst/>
-        </p:spPr>
-        <p:style>
-          <a:lnRef idx="1">
-            <a:schemeClr val="accent1"/>
-          </a:lnRef>
-          <a:fillRef idx="3">
-            <a:schemeClr val="accent1"/>
-          </a:fillRef>
-          <a:effectRef idx="2">
-            <a:schemeClr val="accent1"/>
-          </a:effectRef>
-          <a:fontRef idx="minor">
-            <a:schemeClr val="lt1"/>
-          </a:fontRef>
-        </p:style>
+        </p:spPr>
         <p:txBody>
           <a:bodyPr rtlCol="0" anchor="ctr"/>
           <a:lstStyle/>
@@ -14682,22 +13345,7 @@
           <a:ln>
             <a:noFill/>
           </a:ln>
-          <a:effectLst/>
-        </p:spPr>
-        <p:style>
-          <a:lnRef idx="1">
-            <a:schemeClr val="accent1"/>
-          </a:lnRef>
-          <a:fillRef idx="3">
-            <a:schemeClr val="accent1"/>
-          </a:fillRef>
-          <a:effectRef idx="2">
-            <a:schemeClr val="accent1"/>
-          </a:effectRef>
-          <a:fontRef idx="minor">
-            <a:schemeClr val="lt1"/>
-          </a:fontRef>
-        </p:style>
+        </p:spPr>
         <p:txBody>
           <a:bodyPr rtlCol="0" anchor="ctr"/>
           <a:lstStyle/>
@@ -14728,22 +13376,7 @@
           <a:ln>
             <a:noFill/>
           </a:ln>
-          <a:effectLst/>
-        </p:spPr>
-        <p:style>
-          <a:lnRef idx="1">
-            <a:schemeClr val="accent1"/>
-          </a:lnRef>
-          <a:fillRef idx="3">
-            <a:schemeClr val="accent1"/>
-          </a:fillRef>
-          <a:effectRef idx="2">
-            <a:schemeClr val="accent1"/>
-          </a:effectRef>
-          <a:fontRef idx="minor">
-            <a:schemeClr val="lt1"/>
-          </a:fontRef>
-        </p:style>
+        </p:spPr>
         <p:txBody>
           <a:bodyPr rtlCol="0" anchor="ctr"/>
           <a:lstStyle/>
@@ -14809,22 +13442,7 @@
           <a:ln>
             <a:noFill/>
           </a:ln>
-          <a:effectLst/>
-        </p:spPr>
-        <p:style>
-          <a:lnRef idx="1">
-            <a:schemeClr val="accent1"/>
-          </a:lnRef>
-          <a:fillRef idx="3">
-            <a:schemeClr val="accent1"/>
-          </a:fillRef>
-          <a:effectRef idx="2">
-            <a:schemeClr val="accent1"/>
-          </a:effectRef>
-          <a:fontRef idx="minor">
-            <a:schemeClr val="lt1"/>
-          </a:fontRef>
-        </p:style>
+        </p:spPr>
         <p:txBody>
           <a:bodyPr rtlCol="0" anchor="ctr" lIns="25400" rIns="25400" tIns="0" bIns="0"/>
           <a:lstStyle/>
@@ -14901,22 +13519,7 @@
               <a:srgbClr val="EAE5DD"/>
             </a:solidFill>
           </a:ln>
-          <a:effectLst/>
-        </p:spPr>
-        <p:style>
-          <a:lnRef idx="1">
-            <a:schemeClr val="accent1"/>
-          </a:lnRef>
-          <a:fillRef idx="3">
-            <a:schemeClr val="accent1"/>
-          </a:fillRef>
-          <a:effectRef idx="2">
-            <a:schemeClr val="accent1"/>
-          </a:effectRef>
-          <a:fontRef idx="minor">
-            <a:schemeClr val="lt1"/>
-          </a:fontRef>
-        </p:style>
+        </p:spPr>
         <p:txBody>
           <a:bodyPr rtlCol="0" anchor="ctr"/>
           <a:lstStyle/>
@@ -14945,22 +13548,7 @@
           <a:ln>
             <a:noFill/>
           </a:ln>
-          <a:effectLst/>
-        </p:spPr>
-        <p:style>
-          <a:lnRef idx="1">
-            <a:schemeClr val="accent1"/>
-          </a:lnRef>
-          <a:fillRef idx="3">
-            <a:schemeClr val="accent1"/>
-          </a:fillRef>
-          <a:effectRef idx="2">
-            <a:schemeClr val="accent1"/>
-          </a:effectRef>
-          <a:fontRef idx="minor">
-            <a:schemeClr val="lt1"/>
-          </a:fontRef>
-        </p:style>
+        </p:spPr>
         <p:txBody>
           <a:bodyPr rtlCol="0" anchor="ctr"/>
           <a:lstStyle/>
@@ -15075,22 +13663,7 @@
           <a:ln>
             <a:noFill/>
           </a:ln>
-          <a:effectLst/>
-        </p:spPr>
-        <p:style>
-          <a:lnRef idx="1">
-            <a:schemeClr val="accent1"/>
-          </a:lnRef>
-          <a:fillRef idx="3">
-            <a:schemeClr val="accent1"/>
-          </a:fillRef>
-          <a:effectRef idx="2">
-            <a:schemeClr val="accent1"/>
-          </a:effectRef>
-          <a:fontRef idx="minor">
-            <a:schemeClr val="lt1"/>
-          </a:fontRef>
-        </p:style>
+        </p:spPr>
         <p:txBody>
           <a:bodyPr rtlCol="0" anchor="ctr"/>
           <a:lstStyle/>
@@ -15121,22 +13694,7 @@
           <a:ln>
             <a:noFill/>
           </a:ln>
-          <a:effectLst/>
-        </p:spPr>
-        <p:style>
-          <a:lnRef idx="1">
-            <a:schemeClr val="accent1"/>
-          </a:lnRef>
-          <a:fillRef idx="3">
-            <a:schemeClr val="accent1"/>
-          </a:fillRef>
-          <a:effectRef idx="2">
-            <a:schemeClr val="accent1"/>
-          </a:effectRef>
-          <a:fontRef idx="minor">
-            <a:schemeClr val="lt1"/>
-          </a:fontRef>
-        </p:style>
+        </p:spPr>
         <p:txBody>
           <a:bodyPr rtlCol="0" anchor="ctr"/>
           <a:lstStyle/>
@@ -15202,22 +13760,7 @@
           <a:ln>
             <a:noFill/>
           </a:ln>
-          <a:effectLst/>
-        </p:spPr>
-        <p:style>
-          <a:lnRef idx="1">
-            <a:schemeClr val="accent1"/>
-          </a:lnRef>
-          <a:fillRef idx="3">
-            <a:schemeClr val="accent1"/>
-          </a:fillRef>
-          <a:effectRef idx="2">
-            <a:schemeClr val="accent1"/>
-          </a:effectRef>
-          <a:fontRef idx="minor">
-            <a:schemeClr val="lt1"/>
-          </a:fontRef>
-        </p:style>
+        </p:spPr>
         <p:txBody>
           <a:bodyPr rtlCol="0" anchor="ctr" lIns="25400" rIns="25400" tIns="0" bIns="0"/>
           <a:lstStyle/>
@@ -15294,22 +13837,7 @@
               <a:srgbClr val="EAE5DD"/>
             </a:solidFill>
           </a:ln>
-          <a:effectLst/>
-        </p:spPr>
-        <p:style>
-          <a:lnRef idx="1">
-            <a:schemeClr val="accent1"/>
-          </a:lnRef>
-          <a:fillRef idx="3">
-            <a:schemeClr val="accent1"/>
-          </a:fillRef>
-          <a:effectRef idx="2">
-            <a:schemeClr val="accent1"/>
-          </a:effectRef>
-          <a:fontRef idx="minor">
-            <a:schemeClr val="lt1"/>
-          </a:fontRef>
-        </p:style>
+        </p:spPr>
         <p:txBody>
           <a:bodyPr rtlCol="0" anchor="ctr"/>
           <a:lstStyle/>
@@ -15338,22 +13866,7 @@
           <a:ln>
             <a:noFill/>
           </a:ln>
-          <a:effectLst/>
-        </p:spPr>
-        <p:style>
-          <a:lnRef idx="1">
-            <a:schemeClr val="accent1"/>
-          </a:lnRef>
-          <a:fillRef idx="3">
-            <a:schemeClr val="accent1"/>
-          </a:fillRef>
-          <a:effectRef idx="2">
-            <a:schemeClr val="accent1"/>
-          </a:effectRef>
-          <a:fontRef idx="minor">
-            <a:schemeClr val="lt1"/>
-          </a:fontRef>
-        </p:style>
+        </p:spPr>
         <p:txBody>
           <a:bodyPr rtlCol="0" anchor="ctr"/>
           <a:lstStyle/>
@@ -15468,22 +13981,7 @@
           <a:ln>
             <a:noFill/>
           </a:ln>
-          <a:effectLst/>
-        </p:spPr>
-        <p:style>
-          <a:lnRef idx="1">
-            <a:schemeClr val="accent1"/>
-          </a:lnRef>
-          <a:fillRef idx="3">
-            <a:schemeClr val="accent1"/>
-          </a:fillRef>
-          <a:effectRef idx="2">
-            <a:schemeClr val="accent1"/>
-          </a:effectRef>
-          <a:fontRef idx="minor">
-            <a:schemeClr val="lt1"/>
-          </a:fontRef>
-        </p:style>
+        </p:spPr>
         <p:txBody>
           <a:bodyPr rtlCol="0" anchor="ctr"/>
           <a:lstStyle/>
@@ -15514,22 +14012,7 @@
           <a:ln>
             <a:noFill/>
           </a:ln>
-          <a:effectLst/>
-        </p:spPr>
-        <p:style>
-          <a:lnRef idx="1">
-            <a:schemeClr val="accent1"/>
-          </a:lnRef>
-          <a:fillRef idx="3">
-            <a:schemeClr val="accent1"/>
-          </a:fillRef>
-          <a:effectRef idx="2">
-            <a:schemeClr val="accent1"/>
-          </a:effectRef>
-          <a:fontRef idx="minor">
-            <a:schemeClr val="lt1"/>
-          </a:fontRef>
-        </p:style>
+        </p:spPr>
         <p:txBody>
           <a:bodyPr rtlCol="0" anchor="ctr"/>
           <a:lstStyle/>
@@ -15595,22 +14078,7 @@
           <a:ln>
             <a:noFill/>
           </a:ln>
-          <a:effectLst/>
-        </p:spPr>
-        <p:style>
-          <a:lnRef idx="1">
-            <a:schemeClr val="accent1"/>
-          </a:lnRef>
-          <a:fillRef idx="3">
-            <a:schemeClr val="accent1"/>
-          </a:fillRef>
-          <a:effectRef idx="2">
-            <a:schemeClr val="accent1"/>
-          </a:effectRef>
-          <a:fontRef idx="minor">
-            <a:schemeClr val="lt1"/>
-          </a:fontRef>
-        </p:style>
+        </p:spPr>
         <p:txBody>
           <a:bodyPr rtlCol="0" anchor="ctr" lIns="25400" rIns="25400" tIns="0" bIns="0"/>
           <a:lstStyle/>
@@ -15687,22 +14155,7 @@
               <a:srgbClr val="EAE5DD"/>
             </a:solidFill>
           </a:ln>
-          <a:effectLst/>
-        </p:spPr>
-        <p:style>
-          <a:lnRef idx="1">
-            <a:schemeClr val="accent1"/>
-          </a:lnRef>
-          <a:fillRef idx="3">
-            <a:schemeClr val="accent1"/>
-          </a:fillRef>
-          <a:effectRef idx="2">
-            <a:schemeClr val="accent1"/>
-          </a:effectRef>
-          <a:fontRef idx="minor">
-            <a:schemeClr val="lt1"/>
-          </a:fontRef>
-        </p:style>
+        </p:spPr>
         <p:txBody>
           <a:bodyPr rtlCol="0" anchor="ctr"/>
           <a:lstStyle/>
@@ -15731,22 +14184,7 @@
           <a:ln>
             <a:noFill/>
           </a:ln>
-          <a:effectLst/>
-        </p:spPr>
-        <p:style>
-          <a:lnRef idx="1">
-            <a:schemeClr val="accent1"/>
-          </a:lnRef>
-          <a:fillRef idx="3">
-            <a:schemeClr val="accent1"/>
-          </a:fillRef>
-          <a:effectRef idx="2">
-            <a:schemeClr val="accent1"/>
-          </a:effectRef>
-          <a:fontRef idx="minor">
-            <a:schemeClr val="lt1"/>
-          </a:fontRef>
-        </p:style>
+        </p:spPr>
         <p:txBody>
           <a:bodyPr rtlCol="0" anchor="ctr"/>
           <a:lstStyle/>
@@ -15861,22 +14299,7 @@
           <a:ln>
             <a:noFill/>
           </a:ln>
-          <a:effectLst/>
-        </p:spPr>
-        <p:style>
-          <a:lnRef idx="1">
-            <a:schemeClr val="accent1"/>
-          </a:lnRef>
-          <a:fillRef idx="3">
-            <a:schemeClr val="accent1"/>
-          </a:fillRef>
-          <a:effectRef idx="2">
-            <a:schemeClr val="accent1"/>
-          </a:effectRef>
-          <a:fontRef idx="minor">
-            <a:schemeClr val="lt1"/>
-          </a:fontRef>
-        </p:style>
+        </p:spPr>
         <p:txBody>
           <a:bodyPr rtlCol="0" anchor="ctr"/>
           <a:lstStyle/>
@@ -15907,22 +14330,7 @@
           <a:ln>
             <a:noFill/>
           </a:ln>
-          <a:effectLst/>
-        </p:spPr>
-        <p:style>
-          <a:lnRef idx="1">
-            <a:schemeClr val="accent1"/>
-          </a:lnRef>
-          <a:fillRef idx="3">
-            <a:schemeClr val="accent1"/>
-          </a:fillRef>
-          <a:effectRef idx="2">
-            <a:schemeClr val="accent1"/>
-          </a:effectRef>
-          <a:fontRef idx="minor">
-            <a:schemeClr val="lt1"/>
-          </a:fontRef>
-        </p:style>
+        </p:spPr>
         <p:txBody>
           <a:bodyPr rtlCol="0" anchor="ctr"/>
           <a:lstStyle/>
@@ -15988,22 +14396,7 @@
           <a:ln>
             <a:noFill/>
           </a:ln>
-          <a:effectLst/>
-        </p:spPr>
-        <p:style>
-          <a:lnRef idx="1">
-            <a:schemeClr val="accent1"/>
-          </a:lnRef>
-          <a:fillRef idx="3">
-            <a:schemeClr val="accent1"/>
-          </a:fillRef>
-          <a:effectRef idx="2">
-            <a:schemeClr val="accent1"/>
-          </a:effectRef>
-          <a:fontRef idx="minor">
-            <a:schemeClr val="lt1"/>
-          </a:fontRef>
-        </p:style>
+        </p:spPr>
         <p:txBody>
           <a:bodyPr rtlCol="0" anchor="ctr" lIns="25400" rIns="25400" tIns="0" bIns="0"/>
           <a:lstStyle/>
@@ -16080,22 +14473,7 @@
               <a:srgbClr val="EAE5DD"/>
             </a:solidFill>
           </a:ln>
-          <a:effectLst/>
-        </p:spPr>
-        <p:style>
-          <a:lnRef idx="1">
-            <a:schemeClr val="accent1"/>
-          </a:lnRef>
-          <a:fillRef idx="3">
-            <a:schemeClr val="accent1"/>
-          </a:fillRef>
-          <a:effectRef idx="2">
-            <a:schemeClr val="accent1"/>
-          </a:effectRef>
-          <a:fontRef idx="minor">
-            <a:schemeClr val="lt1"/>
-          </a:fontRef>
-        </p:style>
+        </p:spPr>
         <p:txBody>
           <a:bodyPr rtlCol="0" anchor="ctr"/>
           <a:lstStyle/>
@@ -16126,22 +14504,7 @@
           <a:ln>
             <a:noFill/>
           </a:ln>
-          <a:effectLst/>
-        </p:spPr>
-        <p:style>
-          <a:lnRef idx="1">
-            <a:schemeClr val="accent1"/>
-          </a:lnRef>
-          <a:fillRef idx="3">
-            <a:schemeClr val="accent1"/>
-          </a:fillRef>
-          <a:effectRef idx="2">
-            <a:schemeClr val="accent1"/>
-          </a:effectRef>
-          <a:fontRef idx="minor">
-            <a:schemeClr val="lt1"/>
-          </a:fontRef>
-        </p:style>
+        </p:spPr>
         <p:txBody>
           <a:bodyPr rtlCol="0" anchor="ctr" lIns="25400" rIns="25400" tIns="0" bIns="0"/>
           <a:lstStyle/>
@@ -16216,22 +14579,7 @@
           <a:ln>
             <a:noFill/>
           </a:ln>
-          <a:effectLst/>
-        </p:spPr>
-        <p:style>
-          <a:lnRef idx="1">
-            <a:schemeClr val="accent1"/>
-          </a:lnRef>
-          <a:fillRef idx="3">
-            <a:schemeClr val="accent1"/>
-          </a:fillRef>
-          <a:effectRef idx="2">
-            <a:schemeClr val="accent1"/>
-          </a:effectRef>
-          <a:fontRef idx="minor">
-            <a:schemeClr val="lt1"/>
-          </a:fontRef>
-        </p:style>
+        </p:spPr>
         <p:txBody>
           <a:bodyPr rtlCol="0" anchor="ctr" lIns="25400" rIns="25400" tIns="0" bIns="0"/>
           <a:lstStyle/>
@@ -16306,22 +14654,7 @@
           <a:ln>
             <a:noFill/>
           </a:ln>
-          <a:effectLst/>
-        </p:spPr>
-        <p:style>
-          <a:lnRef idx="1">
-            <a:schemeClr val="accent1"/>
-          </a:lnRef>
-          <a:fillRef idx="3">
-            <a:schemeClr val="accent1"/>
-          </a:fillRef>
-          <a:effectRef idx="2">
-            <a:schemeClr val="accent1"/>
-          </a:effectRef>
-          <a:fontRef idx="minor">
-            <a:schemeClr val="lt1"/>
-          </a:fontRef>
-        </p:style>
+        </p:spPr>
         <p:txBody>
           <a:bodyPr rtlCol="0" anchor="ctr" lIns="25400" rIns="25400" tIns="0" bIns="0"/>
           <a:lstStyle/>
@@ -16396,22 +14729,7 @@
           <a:ln>
             <a:noFill/>
           </a:ln>
-          <a:effectLst/>
-        </p:spPr>
-        <p:style>
-          <a:lnRef idx="1">
-            <a:schemeClr val="accent1"/>
-          </a:lnRef>
-          <a:fillRef idx="3">
-            <a:schemeClr val="accent1"/>
-          </a:fillRef>
-          <a:effectRef idx="2">
-            <a:schemeClr val="accent1"/>
-          </a:effectRef>
-          <a:fontRef idx="minor">
-            <a:schemeClr val="lt1"/>
-          </a:fontRef>
-        </p:style>
+        </p:spPr>
         <p:txBody>
           <a:bodyPr rtlCol="0" anchor="ctr" lIns="25400" rIns="25400" tIns="0" bIns="0"/>
           <a:lstStyle/>

</xml_diff>